<commit_message>
Add simplified paper, 10-slide deck, one-page declaration and sources
- Paper: simplified 3-page mid-term draft; longer version kept in paper/drafts
- Presentation: 10 slides with speaker-note script; generator in presentation/source
- Declaration: one-page project declaration for Manuel, Henrique and João to sign

Co-Authored-By: Claude Opus 5.5 (1M context) <noreply@anthropic.com>
</commit_message>
<xml_diff>
--- a/presentation/midterm-presentation.pptx
+++ b/presentation/midterm-presentation.pptx
@@ -116,19 +116,19 @@
   <p:extLst>
     <p:ext uri="{521415D9-36F7-43E2-AB2F-B90AF26B5E84}">
       <p14:sectionLst xmlns:p14="http://schemas.microsoft.com/office/powerpoint/2010/main">
-        <p14:section name="Opening" id="{e1d2b869-4f3e-fb1b-3b43-39c928b1b304}">
+        <p14:section name="Opening" id="{3b62d4eb-1d1a-554c-45f9-ddfb10ab49a8}">
           <p14:sldIdLst>
             <p14:sldId id="256"/>
             <p14:sldId id="257"/>
           </p14:sldIdLst>
         </p14:section>
-        <p14:section name="Problem framing" id="{2b357017-4d3d-7e0a-d922-4298ba490929}">
+        <p14:section name="Problem framing" id="{8894d24b-8c90-ec69-e66c-bbce993c571c}">
           <p14:sldIdLst>
             <p14:sldId id="258"/>
             <p14:sldId id="259"/>
           </p14:sldIdLst>
         </p14:section>
-        <p14:section name="Sessions" id="{2c5e8a71-14dc-a253-3588-a590dcbcc771}">
+        <p14:section name="Sessions" id="{f83c7e90-c088-4feb-bed0-5410fd9336a1}">
           <p14:sldIdLst>
             <p14:sldId id="260"/>
             <p14:sldId id="261"/>
@@ -137,7 +137,7 @@
             <p14:sldId id="264"/>
           </p14:sldIdLst>
         </p14:section>
-        <p14:section name="Next steps" id="{ede95c5e-d31d-f324-6283-5f19e93f1e0d}">
+        <p14:section name="Next steps" id="{d71ab9ed-1b45-f6f8-12e0-e0162055f957}">
           <p14:sldIdLst>
             <p14:sldId id="265"/>
           </p14:sldIdLst>
@@ -810,7 +810,7 @@
           <a:p>
             <a:r>
               <a:rPr lang="en-US" dirty="0"/>
-              <a:t>Henrique (0:40). This is Manuel, a pseudonym. He's eighty and lives alone in Lisbon. In July his daughter bought him a smartphone so he could join the family WhatsApp group, where the photos of his newborn great-grandson are. He doesn't know how to work it: his taps are too short, gestures do the opposite of what he expects, and the keyboard opens by accident. So it sits uncharged in a drawer. In his words: “They already got it. They did not get me a way to work it.” He corrected our problem statement twice before signing it. [Hand over: “João.” Click]</a:t>
+              <a:t>Henrique (0:40). This is Manuel. He's eighty and lives alone in Lisbon. In July his daughter bought him a smartphone so he could join the family WhatsApp group, where the photos of his newborn great-grandson are. He doesn't know how to work it: his taps are too short, gestures do the opposite of what he expects, and the keyboard opens by accident. So it sits uncharged in a drawer. In his words: “They already got it. They did not get me a way to work it.” He corrected our problem statement twice before signing it. [Hand over: “João.” Click]</a:t>
             </a:r>
             <a:endParaRPr lang="en-US" dirty="0"/>
           </a:p>

</xml_diff>